<commit_message>
Update title slides, fix typo in Lect 5
</commit_message>
<xml_diff>
--- a/presentations/2026SummerSchool/6-2026-PhysicalMathematicsOpenProblems.pptx
+++ b/presentations/2026SummerSchool/6-2026-PhysicalMathematicsOpenProblems.pptx
@@ -253,7 +253,7 @@
           <a:p>
             <a:fld id="{E119C704-B8F9-449B-B828-36D786A1FE73}" type="datetimeFigureOut">
               <a:rPr lang="en-US" smtClean="0"/>
-              <a:t>6/22/2026</a:t>
+              <a:t>6/26/2026</a:t>
             </a:fld>
             <a:endParaRPr lang="en-US"/>
           </a:p>
@@ -667,7 +667,7 @@
           <a:p>
             <a:fld id="{4F827C06-0071-409C-8633-532D54553463}" type="datetime1">
               <a:rPr lang="en-US" smtClean="0"/>
-              <a:t>6/22/2026</a:t>
+              <a:t>6/26/2026</a:t>
             </a:fld>
             <a:endParaRPr lang="en-US"/>
           </a:p>
@@ -1095,7 +1095,7 @@
           <a:p>
             <a:fld id="{12384B1A-0F3A-4F54-8A16-7865AEFE89CD}" type="datetime1">
               <a:rPr lang="en-US" smtClean="0"/>
-              <a:t>6/22/2026</a:t>
+              <a:t>6/26/2026</a:t>
             </a:fld>
             <a:endParaRPr lang="en-US"/>
           </a:p>
@@ -1306,7 +1306,7 @@
           <a:p>
             <a:fld id="{30EF1072-D46C-4FDD-995C-5A3BAD895D62}" type="datetime1">
               <a:rPr lang="en-US" smtClean="0"/>
-              <a:t>6/22/2026</a:t>
+              <a:t>6/26/2026</a:t>
             </a:fld>
             <a:endParaRPr lang="en-US"/>
           </a:p>
@@ -1535,7 +1535,7 @@
           <a:p>
             <a:fld id="{421421C8-42B8-42F2-B138-B2DCA690166A}" type="datetime1">
               <a:rPr lang="en-US" smtClean="0"/>
-              <a:t>6/22/2026</a:t>
+              <a:t>6/26/2026</a:t>
             </a:fld>
             <a:endParaRPr lang="en-US" dirty="0"/>
           </a:p>
@@ -1785,7 +1785,7 @@
           <a:p>
             <a:fld id="{716BED3C-A66A-4563-BF71-615BC8EBC22D}" type="datetime1">
               <a:rPr lang="en-US" smtClean="0"/>
-              <a:t>6/22/2026</a:t>
+              <a:t>6/26/2026</a:t>
             </a:fld>
             <a:endParaRPr lang="en-US"/>
           </a:p>
@@ -2053,7 +2053,7 @@
           <a:p>
             <a:fld id="{8AA75AE8-BB42-46CF-8CD9-BE8DB9BFCE66}" type="datetime1">
               <a:rPr lang="en-US" smtClean="0"/>
-              <a:t>6/22/2026</a:t>
+              <a:t>6/26/2026</a:t>
             </a:fld>
             <a:endParaRPr lang="en-US"/>
           </a:p>
@@ -2468,7 +2468,7 @@
           <a:p>
             <a:fld id="{199040EC-A46D-463D-B9B7-3DFF8D111D65}" type="datetime1">
               <a:rPr lang="en-US" smtClean="0"/>
-              <a:t>6/22/2026</a:t>
+              <a:t>6/26/2026</a:t>
             </a:fld>
             <a:endParaRPr lang="en-US"/>
           </a:p>
@@ -2612,7 +2612,7 @@
           <a:p>
             <a:fld id="{02FF6219-93AC-4A0F-BECB-DDD165FBD6B7}" type="datetime1">
               <a:rPr lang="en-US" smtClean="0"/>
-              <a:t>6/22/2026</a:t>
+              <a:t>6/26/2026</a:t>
             </a:fld>
             <a:endParaRPr lang="en-US"/>
           </a:p>
@@ -2728,7 +2728,7 @@
           <a:p>
             <a:fld id="{AA3F5804-31A0-462E-BBD5-3AFB76B3413F}" type="datetime1">
               <a:rPr lang="en-US" smtClean="0"/>
-              <a:t>6/22/2026</a:t>
+              <a:t>6/26/2026</a:t>
             </a:fld>
             <a:endParaRPr lang="en-US" dirty="0"/>
           </a:p>
@@ -3043,7 +3043,7 @@
           <a:p>
             <a:fld id="{6EBD6A2F-AB05-4308-BDB5-41BDC51901EB}" type="datetime1">
               <a:rPr lang="en-US" smtClean="0"/>
-              <a:t>6/22/2026</a:t>
+              <a:t>6/26/2026</a:t>
             </a:fld>
             <a:endParaRPr lang="en-US"/>
           </a:p>
@@ -3334,7 +3334,7 @@
           <a:p>
             <a:fld id="{08B1076B-5639-46D0-B65F-D1775572D7B6}" type="datetime1">
               <a:rPr lang="en-US" smtClean="0"/>
-              <a:t>6/22/2026</a:t>
+              <a:t>6/26/2026</a:t>
             </a:fld>
             <a:endParaRPr lang="en-US"/>
           </a:p>
@@ -3578,7 +3578,7 @@
           <a:p>
             <a:fld id="{7B7B3F07-64E4-47D2-9C3E-4ED613C06275}" type="datetime1">
               <a:rPr lang="en-US" smtClean="0"/>
-              <a:t>6/22/2026</a:t>
+              <a:t>6/26/2026</a:t>
             </a:fld>
             <a:endParaRPr lang="en-US" dirty="0"/>
           </a:p>
@@ -4342,8 +4342,13 @@
           <a:p>
             <a:r>
               <a:rPr lang="en-US" sz="2400" dirty="0"/>
-              <a:t>Gabriele Carcassi and Christine A. Aidala</a:t>
+              <a:t>Gabriele Carcassi, Christine A. Aidala, and Tobias </a:t>
             </a:r>
+            <a:r>
+              <a:rPr lang="en-US" sz="2400" dirty="0" err="1"/>
+              <a:t>Thrien</a:t>
+            </a:r>
+            <a:endParaRPr lang="en-US" sz="2400" dirty="0"/>
           </a:p>
           <a:p>
             <a:r>
@@ -6355,8 +6360,8 @@
           </a:p>
         </p:txBody>
       </p:sp>
-      <mc:AlternateContent xmlns:mc="http://schemas.openxmlformats.org/markup-compatibility/2006">
-        <mc:Choice xmlns:a14="http://schemas.microsoft.com/office/drawing/2010/main" Requires="a14">
+      <mc:AlternateContent xmlns:mc="http://schemas.openxmlformats.org/markup-compatibility/2006" xmlns:a14="http://schemas.microsoft.com/office/drawing/2010/main">
+        <mc:Choice Requires="a14">
           <p:sp>
             <p:nvSpPr>
               <p:cNvPr id="7" name="TextBox 6">
@@ -6512,7 +6517,7 @@
             </p:txBody>
           </p:sp>
         </mc:Choice>
-        <mc:Fallback>
+        <mc:Fallback xmlns="">
           <p:sp>
             <p:nvSpPr>
               <p:cNvPr id="7" name="TextBox 6">
@@ -46658,8 +46663,8 @@
           </a:p>
         </p:txBody>
       </p:sp>
-      <mc:AlternateContent xmlns:mc="http://schemas.openxmlformats.org/markup-compatibility/2006">
-        <mc:Choice xmlns:a14="http://schemas.microsoft.com/office/drawing/2010/main" Requires="a14">
+      <mc:AlternateContent xmlns:mc="http://schemas.openxmlformats.org/markup-compatibility/2006" xmlns:a14="http://schemas.microsoft.com/office/drawing/2010/main">
+        <mc:Choice Requires="a14">
           <p:sp>
             <p:nvSpPr>
               <p:cNvPr id="3" name="Content Placeholder 2">
@@ -46807,7 +46812,7 @@
             </p:txBody>
           </p:sp>
         </mc:Choice>
-        <mc:Fallback>
+        <mc:Fallback xmlns="">
           <p:sp>
             <p:nvSpPr>
               <p:cNvPr id="3" name="Content Placeholder 2">

</xml_diff>